<commit_message>
Fix the uploaded-file row: details on top, actions underneath
</commit_message>
<xml_diff>
--- a/Kaya_IIT-Hyderabad/docs/Kaya_pitch_deck.pptx
+++ b/Kaya_IIT-Hyderabad/docs/Kaya_pitch_deck.pptx
@@ -1468,7 +1468,10 @@
           <a:p>
             <a:r>
               <a:rPr lang="en-US" dirty="0"/>
-              <a:t>Kaya: a multi-organ digital twin for Type 2 Diabetes. IIT Hyderabad. Team: Dulari Bhushan and Prateek Giddaplavar. Submission to the Happiest Health 'Reimagining and Reforming Healthcare in India' Summit 2026, Digital Twin Challenge, Phase 1.</a:t>
+              <a:t>[Slide 1 | about 0:30 | running total 0:30]
+Good morning. We are Team Kaya from IIT Hyderabad: Dulari Bhushan and Prateek Giddaplavar. Kaya is a multi-organ digital twin for Type 2 Diabetes. Most digital twins forecast glucose. Kaya shows what that glucose is doing to the liver, eyes and kidneys, and lets a doctor test a change on the virtual patient before trying it on the real one.
+---
+Sources and caveats: Kaya: a multi-organ digital twin for Type 2 Diabetes. IIT Hyderabad. Team: Dulari Bhushan and Prateek Giddaplavar. Submission to the Happiest Health 'Reimagining and Reforming Healthcare in India' Summit 2026, Digital Twin Challenge, Phase 1.</a:t>
             </a:r>
             <a:endParaRPr lang="en-US" dirty="0"/>
           </a:p>
@@ -1556,7 +1559,10 @@
           <a:p>
             <a:r>
               <a:rPr lang="en-US" dirty="0"/>
-              <a:t>Features built so far. All data is synthetic. Uploaded reports are shown to the doctor as unverified and are not used by the twin; the twin uses verified panels only. The voice assistant checks emergency words and medicine questions in code before any language model is called, and replaces any reply containing dose advice.</a:t>
+              <a:t>[Slide 10 | about 0:15 | running total 5:25]
+Around the core we built the supporting product: a full patient record, medical reports with trends, a what-changed summary, one action a day with a quick log, an adherence diary, report upload read by Sarvam Document AI, a voice assistant and a one-click clinical PDF. You will see most of these in the demo.
+---
+Sources and caveats: Features built so far. All data is synthetic. Uploaded reports are shown to the doctor as unverified and are not used by the twin; the twin uses verified panels only. The voice assistant checks emergency words and medicine questions in code before any language model is called, and replaces any reply containing dose advice.</a:t>
             </a:r>
             <a:endParaRPr lang="en-US" dirty="0"/>
           </a:p>
@@ -1644,7 +1650,10 @@
           <a:p>
             <a:r>
               <a:rPr lang="en-US" dirty="0"/>
-              <a:t>Screenshots of the running app with a synthetic patient (Rajesh Sharma). Doctor view: triage list sorted by risk, what changed since the last visit, glucose twin with forecast. Patient view: plain-language day summary with one next action, and Try a change, showing time in range and liver-fat risk before and after.</a:t>
+              <a:t>[Slide 11 | about 0:10 | running total 5:35]
+Here is what it looks like: the doctor workspace on the left, the patient app on the right. I will show both live shortly.
+---
+Sources and caveats: Screenshots of the running app with a synthetic patient (Rajesh Sharma). Doctor view: triage list sorted by risk, what changed since the last visit, glucose twin with forecast. Patient view: plain-language day summary with one next action, and Try a change, showing time in range and liver-fat risk before and after.</a:t>
             </a:r>
             <a:endParaRPr lang="en-US" dirty="0"/>
           </a:p>
@@ -1732,7 +1741,10 @@
           <a:p>
             <a:r>
               <a:rPr lang="en-US" dirty="0"/>
-              <a:t>System architecture. Inputs (wearable stream, EHR and labs, retina scan, patient quick log, voice or chat) feed one patient-state encoder. Four organ modules and the what-if engine sit on top. Three roles use the product: patient, doctor and admin. The dashed loop shows patient logs and questions feeding back into the twin.</a:t>
+              <a:t>[Slide 12 | about 0:35 | running total 6:10]
+This is the architecture. On top, five inputs: the wearable stream, EHR and labs, the retina scan, the patient's quick log and voice. They feed one patient-state encoder, then four organ modules and the what-if engine. Below are the three roles, patient, doctor and admin, all served by one REST API. The dashed loop shows patient logs and questions feeding back into the twin.
+---
+Sources and caveats: System architecture. Inputs (wearable stream, EHR and labs, retina scan, patient quick log, voice or chat) feed one patient-state encoder. Four organ modules and the what-if engine sit on top. Three roles use the product: patient, doctor and admin. The dashed loop shows patient logs and questions feeding back into the twin.</a:t>
             </a:r>
             <a:endParaRPr lang="en-US" dirty="0"/>
           </a:p>
@@ -1820,7 +1832,10 @@
           <a:p>
             <a:r>
               <a:rPr lang="en-US" dirty="0"/>
-              <a:t>Glucose: out-of-sample on real CGMacros recordings (34 subjects): RMSE 12.6 / 21.1 / 28.2 mg/dL at 30 / 60 / 120 minutes versus 16.3 / 25.8 / 36.7 for no-change; conformal 80% intervals cover about 80%; event probabilities are isotonic-calibrated. Liver: NHANES 2017-18, 4,745 adults with FibroScan labels: advanced fibrosis AUROC 0.83 versus FIB-4 0.63; steatosis 0.83 versus FLI 0.82. Kidney: NHANES, 4,827 adults: low eGFR 0.85 (same as a simple baseline), albuminuria 0.76; the product value is the eGFR path, which is a labelled simulation. Eye: EfficientNet-B2 ordinal grader, kappa 0.89 on APTOS held-out, 0.71 on Indian IDRiD after fine-tuning (0.57 without). Progression risk is a simulation with editable assumptions.</a:t>
+              <a:t>[Slide 13 | about 0:40 | running total 6:50]
+The models, each tested on real data. Glucose: a GRU blended with LightGBM beats a no-change baseline at every horizon, about 21 versus 26 mg/dL error at one hour, with intervals that really cover 80 percent. Liver: trained on 4,745 real adults from NHANES, it reaches 0.83 AUROC for advanced fibrosis against 0.63 for the standard FIB-4 score. Kidney matches a strong simple baseline at 0.85, so our value there is the eGFR trajectory, which we label as a simulation. Eye: EfficientNet-B2 reaches kappa 0.89 on APTOS, and 0.71 on the Indian IDRiD set after fine-tuning.
+---
+Sources and caveats: Glucose: out-of-sample on real CGMacros recordings (34 subjects): RMSE 12.6 / 21.1 / 28.2 mg/dL at 30 / 60 / 120 minutes versus 16.3 / 25.8 / 36.7 for no-change; conformal 80% intervals cover about 80%; event probabilities are isotonic-calibrated. Liver: NHANES 2017-18, 4,745 adults with FibroScan labels: advanced fibrosis AUROC 0.83 versus FIB-4 0.63; steatosis 0.83 versus FLI 0.82. Kidney: NHANES, 4,827 adults: low eGFR 0.85 (same as a simple baseline), albuminuria 0.76; the product value is the eGFR path, which is a labelled simulation. Eye: EfficientNet-B2 ordinal grader, kappa 0.89 on APTOS held-out, 0.71 on Indian IDRiD after fine-tuning (0.57 without). Progression risk is a simulation with editable assumptions.</a:t>
             </a:r>
             <a:endParaRPr lang="en-US" dirty="0"/>
           </a:p>
@@ -1908,7 +1923,10 @@
           <a:p>
             <a:r>
               <a:rPr lang="en-US" dirty="0"/>
-              <a:t>Technical stack. Data: CGMacros (PhysioNet), NHANES 2017-18, APTOS 2019 and IDRiD, and a synthetic cohort (our generator plus simglucose). Models: PyTorch GRU with quantile and event heads, LightGBM, scikit-learn, timm EfficientNet-B2, SHAP, Grad-CAM, conformal prediction and isotonic calibration. Language: Sarvam AI (saaras:v4 speech-to-text, sarvam-105b-conversations chat, bulbul:v4-flash text-to-speech) and Sarvam Document AI, all called from the server so the key never reaches the browser. Platform: FastAPI, Pydantic, WebSocket, FHIR R4, ReportLab PDFs, React 18 with Vite, NumPy live model, Docker Compose and GitHub Actions. Training used 3x NVIDIA RTX A5000.</a:t>
+              <a:t>[Slide 14 | about 0:15 | running total 7:05]
+The stack is deliberately simple: open data, PyTorch and LightGBM models, SHAP and Grad-CAM for explanations, Sarvam AI for Indian-language voice and document reading, and FastAPI, React and Docker. The live model runs in pure NumPy, so the demo needs no GPU.
+---
+Sources and caveats: Technical stack. Data: CGMacros (PhysioNet), NHANES 2017-18, APTOS 2019 and IDRiD, and a synthetic cohort (our generator plus simglucose). Models: PyTorch GRU with quantile and event heads, LightGBM, scikit-learn, timm EfficientNet-B2, SHAP, Grad-CAM, conformal prediction and isotonic calibration. Language: Sarvam AI (saaras:v4 speech-to-text, sarvam-105b-conversations chat, bulbul:v4-flash text-to-speech) and Sarvam Document AI, all called from the server so the key never reaches the browser. Platform: FastAPI, Pydantic, WebSocket, FHIR R4, ReportLab PDFs, React 18 with Vite, NumPy live model, Docker Compose and GitHub Actions. Training used 3x NVIDIA RTX A5000.</a:t>
             </a:r>
             <a:endParaRPr lang="en-US" dirty="0"/>
           </a:p>
@@ -1996,7 +2014,10 @@
           <a:p>
             <a:r>
               <a:rPr lang="en-US" dirty="0"/>
-              <a:t>Three roles. Patient: the app shows one next action and why, how habits affect organs, a try-a-change simulator, and a voice assistant in four languages; patients can upload reports as PDF or photo. Doctor: triaged list, full record, what changed, what-if, PDF. Admin: operations page with service health, model inventory, traffic, assistant safety counters, audit trail (in memory), self-test and a hardening checklist; FHIR R4 read API for hospital IT. Persistent audit log, consent records and ABDM alignment are on the roadmap.</a:t>
+              <a:t>[Slide 15 | about 0:35 | running total 7:40]
+Who is it for? Three people. The patient gets one clear next action each day, sees how habits affect organs, can try a change before making it, and asks questions by voice in their own language. The doctor sees who needs help today and why, opens a full record, sees what changed since the last visit, and tests a what-if before changing treatment. The admin, meaning clinic administrators and hospital IT, sees service health, which models are running and how they were validated, an audit trail and a self-test.
+---
+Sources and caveats: Three roles. Patient: the app shows one next action and why, how habits affect organs, a try-a-change simulator, and a voice assistant in four languages; patients can upload reports as PDF or photo. Doctor: triaged list, full record, what changed, what-if, PDF. Admin: operations page with service health, model inventory, traffic, assistant safety counters, audit trail (in memory), self-test and a hardening checklist; FHIR R4 read API for hospital IT. Persistent audit log, consent records and ABDM alignment are on the roadmap.</a:t>
             </a:r>
             <a:endParaRPr lang="en-US" dirty="0"/>
           </a:p>
@@ -2084,7 +2105,10 @@
           <a:p>
             <a:r>
               <a:rPr lang="en-US" dirty="0"/>
-              <a:t>Status as of this submission. The glucose-to-organ links are simulated because no public dataset links one person's glucose stream to their liver, eye and kidney outcomes; each module is validated on real data where it exists (CGMacros, NHANES, APTOS and IDRiD).</a:t>
+              <a:t>[Slide 16 | about 0:30 | running total 8:10]
+Where we are, honestly. Built: the four modules, what-if and live mode, three role views, four languages with voice, report upload, a FHIR read API and automated tests. Next: consent records, a persistent audit log, sign-in before any real data, ABDM alignment and a pilot with a hospital partner. And what we state openly: Kaya is decision support, not a diagnostic device, and the glucose-to-organ links are simulated on a synthetic cohort and not yet clinically validated.
+---
+Sources and caveats: Status as of this submission. The glucose-to-organ links are simulated because no public dataset links one person's glucose stream to their liver, eye and kidney outcomes; each module is validated on real data where it exists (CGMacros, NHANES, APTOS and IDRiD).</a:t>
             </a:r>
             <a:endParaRPr lang="en-US" dirty="0"/>
           </a:p>
@@ -2172,7 +2196,10 @@
           <a:p>
             <a:r>
               <a:rPr lang="en-US" dirty="0"/>
-              <a:t>Closing. Thank the judges; offer the live demo: doctor view, patient view and admin view on synthetic patients.</a:t>
+              <a:t>[Slide 17 | about 0:15 | running total 8:25]
+To close: Kaya gives every patient a living twin, every doctor a way to test a change first, and every clinic a platform it can run safely. Let me show you. [Switch to the live demo.]
+---
+Sources and caveats: Closing. Thank the judges; offer the live demo: doctor view, patient view and admin view on synthetic patients.</a:t>
             </a:r>
             <a:endParaRPr lang="en-US" dirty="0"/>
           </a:p>
@@ -2260,7 +2287,10 @@
           <a:p>
             <a:r>
               <a:rPr lang="en-US" dirty="0"/>
-              <a:t>Appendix: detailed architecture with data sources, models, trust features and what people get. Footnotes give dataset names, model names and headline metrics.</a:t>
+              <a:t>[Appendix]
+Appendix: detailed architecture with data sources, models and footnotes. Not part of the talk; open it only if asked.
+---
+Sources and caveats: Appendix: detailed architecture with data sources, models, trust features and what people get. Footnotes give dataset names, model names and headline metrics.</a:t>
             </a:r>
             <a:endParaRPr lang="en-US" dirty="0"/>
           </a:p>
@@ -2348,7 +2378,10 @@
           <a:p>
             <a:r>
               <a:rPr lang="en-US" dirty="0"/>
-              <a:t>Preface. The disease is rarely fatal by itself; complications are. Existing apps and twins focus on managing sugar. Kaya connects the continuous glucose signal to organ damage. The chart is illustrative: continuous glucose versus an annual organ check.</a:t>
+              <a:t>[Slide 2 | about 0:35 | running total 1:05]
+Diabetes by itself rarely kills. The damage comes from complications that build silently over years: fatty liver turning into fibrosis, retinopathy found only after vision is lost, kidney function slowly declining. Today we watch sugar closely, with a reading every day, but the organs are checked once a year, if at all. Kaya connects those two worlds. It is a living virtual copy of each patient that links daily glucose to the organs it harms.
+---
+Sources and caveats: Preface. The disease is rarely fatal by itself; complications are. Existing apps and twins focus on managing sugar. Kaya connects the continuous glucose signal to organ damage. The chart is illustrative: continuous glucose versus an annual organ check.</a:t>
             </a:r>
             <a:endParaRPr lang="en-US" dirty="0"/>
           </a:p>
@@ -2436,7 +2469,10 @@
           <a:p>
             <a:r>
               <a:rPr lang="en-US" dirty="0"/>
-              <a:t>Scale: ICMR-INDIAB (2023) estimates 101 million Indians with diabetes (11.4%) and 136 million with prediabetes (15.3%). IDF Atlas 2025: about 89.8 million adults aged 20-79 in 2024 (second only to China), 43% undiagnosed, projected 156.7 million by 2050. Control: in the ICMR-INDIAB national study of 5,789 people with known diabetes, 36.3% had good glycaemic control, 48.8% good blood pressure control, 41.5% LDL on target, and only 7.7% met all three. The IDF India figures come from a news summary of the Atlas; verify against the Atlas before final submission.</a:t>
+              <a:t>[Slide 3 | about 0:40 | running total 1:45]
+Now the scale in India. The ICMR-INDIAB survey estimates about 101 million Indians live with diabetes, and another 136 million have prediabetes. The IDF estimates that 43 percent of adults with diabetes do not know they have it, and projects around 157 million by 2050. Even among people who know, control is poor: about 36 percent reach their sugar target, and only 7.7 percent reach sugar, blood pressure and cholesterol targets together. This is the population where complications are quietly building.
+---
+Sources and caveats: Scale: ICMR-INDIAB (2023) estimates 101 million Indians with diabetes (11.4%) and 136 million with prediabetes (15.3%). IDF Atlas 2025: about 89.8 million adults aged 20-79 in 2024 (second only to China), 43% undiagnosed, projected 156.7 million by 2050. Control: in the ICMR-INDIAB national study of 5,789 people with known diabetes, 36.3% had good glycaemic control, 48.8% good blood pressure control, 41.5% LDL on target, and only 7.7% met all three. The IDF India figures come from a news summary of the Atlas; verify against the Atlas before final submission.</a:t>
             </a:r>
             <a:endParaRPr lang="en-US" dirty="0"/>
           </a:p>
@@ -2524,7 +2560,10 @@
           <a:p>
             <a:r>
               <a:rPr lang="en-US" dirty="0"/>
-              <a:t>Complications. Eyes: National Diabetic Retinopathy Survey 2015-19 (21 districts, age 50+): DR in 16.9% of people with diabetes, sight-threatening 3.6%. Kidneys: Indian hospital studies report albuminuria or CKD in roughly 34-44% of people with type 2 diabetes (Delhi 34.4%, Kolkata 43.8% with UACR above 30); these are single-centre studies, not national. Liver: SPRINT (924 patients, 101 cities) found NAFLD in 56.5%; DiaFib-Liver (9,202 adults) found clinically significant fibrosis in 26%, advanced fibrosis in 14%.</a:t>
+              <a:t>[Slide 4 | about 0:40 | running total 2:25]
+What goes wrong when sugar stays high for years? Eyes: in the national retinopathy survey, about 17 percent of people with diabetes over 50 had retinopathy, and 3.6 percent already had sight-threatening disease. Kidneys: Indian clinic studies report kidney damage in roughly a third to nearly half of patients. Liver: more than half of Indians with type 2 diabetes have fatty liver, and about a quarter already have significant fibrosis. The kidney and liver numbers come from clinic studies, not national surveys, and every one of these is silent until it is late.
+---
+Sources and caveats: Complications. Eyes: National Diabetic Retinopathy Survey 2015-19 (21 districts, age 50+): DR in 16.9% of people with diabetes, sight-threatening 3.6%. Kidneys: Indian hospital studies report albuminuria or CKD in roughly 34-44% of people with type 2 diabetes (Delhi 34.4%, Kolkata 43.8% with UACR above 30); these are single-centre studies, not national. Liver: SPRINT (924 patients, 101 cities) found NAFLD in 56.5%; DiaFib-Liver (9,202 adults) found clinically significant fibrosis in 26%, advanced fibrosis in 14%.</a:t>
             </a:r>
             <a:endParaRPr lang="en-US" dirty="0"/>
           </a:p>
@@ -2612,7 +2651,10 @@
           <a:p>
             <a:r>
               <a:rPr lang="en-US" dirty="0"/>
-              <a:t>Why the damage is missed. The timeline is conceptual. Ophthalmologist density is from World Diabetes Foundation project pages (about 1 per 100,000, about 80% in cities); these figures are dated and should be re-checked.</a:t>
+              <a:t>[Slide 5 | about 0:35 | running total 3:00]
+Why is it found so late? Three reasons. Checks are rare, and many people are undiagnosed. Specialists are scarce: about one ophthalmologist per hundred thousand people, most of them in cities. And data sits in silos: glucose sensors, lab reports and eye scans live apart, and nobody links daily glucose to organ damage. So the first alarm is often blindness, dialysis or cirrhosis. We want the flag to come years earlier.
+---
+Sources and caveats: Why the damage is missed. The timeline is conceptual. Ophthalmologist density is from World Diabetes Foundation project pages (about 1 per 100,000, about 80% in cities); these figures are dated and should be re-checked.</a:t>
             </a:r>
             <a:endParaRPr lang="en-US" dirty="0"/>
           </a:p>
@@ -2700,7 +2742,10 @@
           <a:p>
             <a:r>
               <a:rPr lang="en-US" dirty="0"/>
-              <a:t>Market landscape, based on public information. Twin Health markets a whole-body metabolic digital twin for reversing type 2 diabetes using CGM, sleep, activity and stress data; its public descriptions do not describe per-organ risk or a clinician what-if tool. Verify competitor claims before the final submission. India diabetes device market is estimated at USD 4.8 billion, reaching 7.7 billion by 2030 (Frost &amp; Sullivan, via BioSpectrum).</a:t>
+              <a:t>[Slide 6 | about 0:35 | running total 3:35]
+What exists today? CGMs and meters, from companies like Abbott, Dexcom and Medtronic, give accurate glucose but stop there. Coaching apps like Sugar.fit, BeatO and Fitterfly help with habits, again around sugar. Twin Health offers a metabolic twin focused on remission. And single-organ tools, such as AI retina screening or FibroScan, are strong but they are snapshots, each in its own silo.
+---
+Sources and caveats: Market landscape, based on public information. Twin Health markets a whole-body metabolic digital twin for reversing type 2 diabetes using CGM, sleep, activity and stress data; its public descriptions do not describe per-organ risk or a clinician what-if tool. Verify competitor claims before the final submission. India diabetes device market is estimated at USD 4.8 billion, reaching 7.7 billion by 2030 (Frost &amp; Sullivan, via BioSpectrum).</a:t>
             </a:r>
             <a:endParaRPr lang="en-US" dirty="0"/>
           </a:p>
@@ -2788,7 +2833,10 @@
           <a:p>
             <a:r>
               <a:rPr lang="en-US" dirty="0"/>
-              <a:t>Comparison is based on public product descriptions and should be verified before the final submission. Kaya's coaching is limited to nudges (a next action and why), so it is marked partial. Kaya's organ modules are validated on real data where it exists (NHANES, APTOS and IDRiD, CGMacros); the glucose-to-organ links are simulated on a synthetic cohort and not clinically validated.</a:t>
+              <a:t>[Slide 7 | about 0:30 | running total 4:05]
+Side by side, glucose tracking is well covered. But liver risk from daily glucose, retinopathy progression, a kidney trajectory, a what-if tool for the doctor, and a patient app in Indian languages with voice: almost nobody connects these. That is the gap Kaya is built for. This comparison is based on public product descriptions.
+---
+Sources and caveats: Comparison is based on public product descriptions and should be verified before the final submission. Kaya's coaching is limited to nudges (a next action and why), so it is marked partial. Kaya's organ modules are validated on real data where it exists (NHANES, APTOS and IDRiD, CGMacros); the glucose-to-organ links are simulated on a synthetic cohort and not clinically validated.</a:t>
             </a:r>
             <a:endParaRPr lang="en-US" dirty="0"/>
           </a:p>
@@ -2876,7 +2924,10 @@
           <a:p>
             <a:r>
               <a:rPr lang="en-US" dirty="0"/>
-              <a:t>Kaya fuses static EHR data and dynamic wearable data into one twin per patient, runs four organ modules (glucose, liver, eye, kidney) and a what-if engine. Glucose forecast re-runs on each 5-minute reading using a pure NumPy model in about 1 ms with no GPU. Three roles use it: patient, doctor and admin.</a:t>
+              <a:t>[Slide 8 | about 0:35 | running total 4:40]
+So, Kaya, in three ideas. One, fuse: we combine hospital records and labs, wearable glucose, heart rate and sleep, and the retina scan into one twin per patient. Two, foresee: we forecast glucose two hours ahead and estimate liver, eye and kidney risk and where each is heading, with honest uncertainty. Three, test first: a doctor or the patient changes a meal, a walk or a medicine on the twin and sees the effect before doing it for real. It runs at about a millisecond per reading, with no GPU.
+---
+Sources and caveats: Kaya fuses static EHR data and dynamic wearable data into one twin per patient, runs four organ modules (glucose, liver, eye, kidney) and a what-if engine. Glucose forecast re-runs on each 5-minute reading using a pure NumPy model in about 1 ms with no GPU. Three roles use it: patient, doctor and admin.</a:t>
             </a:r>
             <a:endParaRPr lang="en-US" dirty="0"/>
           </a:p>
@@ -2964,7 +3015,10 @@
           <a:p>
             <a:r>
               <a:rPr lang="en-US" dirty="0"/>
-              <a:t>Mapping from market gaps (previous slides) to what Kaya has built. Alert replay: at about one false alert per patient-day, 72% of hypoglycaemia episodes are caught with a median 45 minutes of warning. The retina grader reaches quadratic kappa 0.71 on the Indian IDRiD test set after fine-tuning.</a:t>
+              <a:t>[Slide 9 | about 0:30 | running total 5:10]
+Every gap we found has an answer. It stops at glucose: we link glucose to three organs. No way to test a change: the what-if engine. Black-box scores: every alert shows its reason, with SHAP drivers and a retina heat-map. Not built for India: four languages with voice, and a retina grader tested on an Indian dataset. Snapshots: live mode re-forecasts every five minutes and catches 72 percent of lows about 45 minutes ahead. Hard to run: a FHIR API, Docker, and an admin page.
+---
+Sources and caveats: Mapping from market gaps (previous slides) to what Kaya has built. Alert replay: at about one false alert per patient-day, 72% of hypoglycaemia episodes are caught with a median 45 minutes of warning. The retina grader reaches quadratic kappa 0.71 on the Indian IDRiD test set after fine-tuning.</a:t>
             </a:r>
             <a:endParaRPr lang="en-US" dirty="0"/>
           </a:p>
@@ -3060,9 +3114,33 @@
           <a:chExt cx="0" cy="0"/>
         </a:xfrm>
       </p:grpSpPr>
-      <p:sp>
-        <p:nvSpPr>
-          <p:cNvPr id="2" name="Text 0"/>
+      <p:pic>
+        <p:nvPicPr>
+          <p:cNvPr id="2" name="Image 0" descr="C:\Users\dular\AppData\Local\Temp\claude\C--Users-dular-Documents-GitHub-digital-Twin-for-healthcare\e2aeb626-02d4-4787-bc69-9973ee664942\scratchpad\deck\logo_mark.png">    </p:cNvPr>
+          <p:cNvPicPr>
+            <a:picLocks noChangeAspect="1"/>
+          </p:cNvPicPr>
+          <p:nvPr/>
+        </p:nvPicPr>
+        <p:blipFill>
+          <a:blip r:embed="rId1"/>
+          <a:stretch>
+            <a:fillRect/>
+          </a:stretch>
+        </p:blipFill>
+        <p:spPr>
+          <a:xfrm>
+            <a:off x="8229600" y="246888"/>
+            <a:ext cx="402336" cy="297180"/>
+          </a:xfrm>
+          <a:prstGeom prst="rect">
+            <a:avLst/>
+          </a:prstGeom>
+        </p:spPr>
+      </p:pic>
+      <p:sp>
+        <p:nvSpPr>
+          <p:cNvPr id="3" name="Text 0"/>
           <p:cNvSpPr/>
           <p:nvPr/>
         </p:nvSpPr>
@@ -3608,7 +3686,7 @@
                   <a:srgbClr val="0F3B38"/>
                 </a:solidFill>
               </a:rPr>
-              <a:t>A multi-organ digital twin for Type 2 Diabetes</a:t>
+              <a:t>A Multi-Organ Digital Twin for Type 2 Diabetes</a:t>
             </a:r>
             <a:endParaRPr lang="en-US" sz="2800" dirty="0"/>
           </a:p>
@@ -13941,41 +14019,40 @@
           </a:effectLst>
         </p:spPr>
       </p:sp>
-      <p:sp>
-        <p:nvSpPr>
-          <p:cNvPr id="5" name="Shape 3"/>
-          <p:cNvSpPr/>
-          <p:nvPr/>
-        </p:nvSpPr>
-        <p:spPr>
-          <a:xfrm rot="18900000">
-            <a:off x="1280160" y="1737360"/>
-            <a:ext cx="548640" cy="548640"/>
-          </a:xfrm>
-          <a:prstGeom prst="teardrop">
-            <a:avLst/>
-          </a:prstGeom>
-          <a:solidFill>
-            <a:srgbClr val="E5484D"/>
-          </a:solidFill>
-          <a:ln w="12700">
-            <a:solidFill>
-              <a:srgbClr val="E5484D"/>
-            </a:solidFill>
-            <a:prstDash val="solid"/>
-          </a:ln>
-        </p:spPr>
-      </p:sp>
-      <p:sp>
-        <p:nvSpPr>
-          <p:cNvPr id="6" name="Text 4"/>
-          <p:cNvSpPr txBox="1"/>
-          <p:nvPr/>
-        </p:nvSpPr>
-        <p:spPr>
-          <a:xfrm>
-            <a:off x="640080" y="2423160"/>
-            <a:ext cx="1828800" cy="365760"/>
+      <p:pic>
+        <p:nvPicPr>
+          <p:cNvPr id="5" name="Image 0" descr="Glucose meter and blood drop">    </p:cNvPr>
+          <p:cNvPicPr>
+            <a:picLocks noChangeAspect="1"/>
+          </p:cNvPicPr>
+          <p:nvPr/>
+        </p:nvPicPr>
+        <p:blipFill>
+          <a:blip r:embed="rId1"/>
+          <a:stretch>
+            <a:fillRect/>
+          </a:stretch>
+        </p:blipFill>
+        <p:spPr>
+          <a:xfrm>
+            <a:off x="914400" y="1627632"/>
+            <a:ext cx="1280160" cy="1216152"/>
+          </a:xfrm>
+          <a:prstGeom prst="rect">
+            <a:avLst/>
+          </a:prstGeom>
+        </p:spPr>
+      </p:pic>
+      <p:sp>
+        <p:nvSpPr>
+          <p:cNvPr id="6" name="Text 3"/>
+          <p:cNvSpPr txBox="1"/>
+          <p:nvPr/>
+        </p:nvSpPr>
+        <p:spPr>
+          <a:xfrm>
+            <a:off x="640080" y="2926080"/>
+            <a:ext cx="1828800" cy="320040"/>
           </a:xfrm>
           <a:prstGeom prst="rect">
             <a:avLst/>
@@ -14004,14 +14081,14 @@
       </p:sp>
       <p:sp>
         <p:nvSpPr>
-          <p:cNvPr id="7" name="Text 5"/>
-          <p:cNvSpPr txBox="1"/>
-          <p:nvPr/>
-        </p:nvSpPr>
-        <p:spPr>
-          <a:xfrm>
-            <a:off x="685800" y="2788920"/>
-            <a:ext cx="1737360" cy="548640"/>
+          <p:cNvPr id="7" name="Text 4"/>
+          <p:cNvSpPr txBox="1"/>
+          <p:nvPr/>
+        </p:nvSpPr>
+        <p:spPr>
+          <a:xfrm>
+            <a:off x="685800" y="3264408"/>
+            <a:ext cx="1737360" cy="457200"/>
           </a:xfrm>
           <a:prstGeom prst="rect">
             <a:avLst/>
@@ -14040,14 +14117,14 @@
       </p:sp>
       <p:sp>
         <p:nvSpPr>
-          <p:cNvPr id="8" name="Text 6"/>
-          <p:cNvSpPr txBox="1"/>
-          <p:nvPr/>
-        </p:nvSpPr>
-        <p:spPr>
-          <a:xfrm>
-            <a:off x="685800" y="3611880"/>
-            <a:ext cx="1737360" cy="548640"/>
+          <p:cNvPr id="8" name="Text 5"/>
+          <p:cNvSpPr txBox="1"/>
+          <p:nvPr/>
+        </p:nvSpPr>
+        <p:spPr>
+          <a:xfrm>
+            <a:off x="685800" y="3840480"/>
+            <a:ext cx="1737360" cy="457200"/>
           </a:xfrm>
           <a:prstGeom prst="rect">
             <a:avLst/>
@@ -14076,7 +14153,7 @@
       </p:sp>
       <p:sp>
         <p:nvSpPr>
-          <p:cNvPr id="9" name="Shape 7"/>
+          <p:cNvPr id="9" name="Shape 6"/>
           <p:cNvSpPr/>
           <p:nvPr/>
         </p:nvSpPr>
@@ -14100,7 +14177,7 @@
       </p:sp>
       <p:sp>
         <p:nvSpPr>
-          <p:cNvPr id="10" name="Shape 8"/>
+          <p:cNvPr id="10" name="Shape 7"/>
           <p:cNvSpPr/>
           <p:nvPr/>
         </p:nvSpPr>
@@ -14134,7 +14211,7 @@
       </p:sp>
       <p:sp>
         <p:nvSpPr>
-          <p:cNvPr id="11" name="Shape 9"/>
+          <p:cNvPr id="11" name="Shape 8"/>
           <p:cNvSpPr/>
           <p:nvPr/>
         </p:nvSpPr>
@@ -14159,14 +14236,14 @@
       </p:sp>
       <p:pic>
         <p:nvPicPr>
-          <p:cNvPr id="12" name="Image 0" descr="Eyes illustration">    </p:cNvPr>
+          <p:cNvPr id="12" name="Image 1" descr="Eyes illustration">    </p:cNvPr>
           <p:cNvPicPr>
             <a:picLocks noChangeAspect="1"/>
           </p:cNvPicPr>
           <p:nvPr/>
         </p:nvPicPr>
         <p:blipFill>
-          <a:blip r:embed="rId1"/>
+          <a:blip r:embed="rId2"/>
           <a:srcRect l="0" r="0" t="0" b="0"/>
           <a:stretch/>
         </p:blipFill>
@@ -14182,7 +14259,7 @@
       </p:pic>
       <p:sp>
         <p:nvSpPr>
-          <p:cNvPr id="13" name="Text 10"/>
+          <p:cNvPr id="13" name="Text 9"/>
           <p:cNvSpPr txBox="1"/>
           <p:nvPr/>
         </p:nvSpPr>
@@ -14218,7 +14295,7 @@
       </p:sp>
       <p:sp>
         <p:nvSpPr>
-          <p:cNvPr id="14" name="Text 11"/>
+          <p:cNvPr id="14" name="Text 10"/>
           <p:cNvSpPr txBox="1"/>
           <p:nvPr/>
         </p:nvSpPr>
@@ -14254,7 +14331,7 @@
       </p:sp>
       <p:sp>
         <p:nvSpPr>
-          <p:cNvPr id="15" name="Text 12"/>
+          <p:cNvPr id="15" name="Text 11"/>
           <p:cNvSpPr txBox="1"/>
           <p:nvPr/>
         </p:nvSpPr>
@@ -14290,7 +14367,7 @@
       </p:sp>
       <p:sp>
         <p:nvSpPr>
-          <p:cNvPr id="16" name="Text 13"/>
+          <p:cNvPr id="16" name="Text 12"/>
           <p:cNvSpPr txBox="1"/>
           <p:nvPr/>
         </p:nvSpPr>
@@ -14326,7 +14403,7 @@
       </p:sp>
       <p:sp>
         <p:nvSpPr>
-          <p:cNvPr id="17" name="Shape 14"/>
+          <p:cNvPr id="17" name="Shape 13"/>
           <p:cNvSpPr/>
           <p:nvPr/>
         </p:nvSpPr>
@@ -14350,7 +14427,7 @@
       </p:sp>
       <p:sp>
         <p:nvSpPr>
-          <p:cNvPr id="18" name="Shape 15"/>
+          <p:cNvPr id="18" name="Shape 14"/>
           <p:cNvSpPr/>
           <p:nvPr/>
         </p:nvSpPr>
@@ -14384,7 +14461,7 @@
       </p:sp>
       <p:sp>
         <p:nvSpPr>
-          <p:cNvPr id="19" name="Shape 16"/>
+          <p:cNvPr id="19" name="Shape 15"/>
           <p:cNvSpPr/>
           <p:nvPr/>
         </p:nvSpPr>
@@ -14409,14 +14486,14 @@
       </p:sp>
       <p:pic>
         <p:nvPicPr>
-          <p:cNvPr id="20" name="Image 1" descr="Kidneys illustration">    </p:cNvPr>
+          <p:cNvPr id="20" name="Image 2" descr="Kidneys illustration">    </p:cNvPr>
           <p:cNvPicPr>
             <a:picLocks noChangeAspect="1"/>
           </p:cNvPicPr>
           <p:nvPr/>
         </p:nvPicPr>
         <p:blipFill>
-          <a:blip r:embed="rId2"/>
+          <a:blip r:embed="rId3"/>
           <a:srcRect l="0" r="0" t="0" b="0"/>
           <a:stretch/>
         </p:blipFill>
@@ -14432,7 +14509,7 @@
       </p:pic>
       <p:sp>
         <p:nvSpPr>
-          <p:cNvPr id="21" name="Text 17"/>
+          <p:cNvPr id="21" name="Text 16"/>
           <p:cNvSpPr txBox="1"/>
           <p:nvPr/>
         </p:nvSpPr>
@@ -14468,7 +14545,7 @@
       </p:sp>
       <p:sp>
         <p:nvSpPr>
-          <p:cNvPr id="22" name="Text 18"/>
+          <p:cNvPr id="22" name="Text 17"/>
           <p:cNvSpPr txBox="1"/>
           <p:nvPr/>
         </p:nvSpPr>
@@ -14504,7 +14581,7 @@
       </p:sp>
       <p:sp>
         <p:nvSpPr>
-          <p:cNvPr id="23" name="Text 19"/>
+          <p:cNvPr id="23" name="Text 18"/>
           <p:cNvSpPr txBox="1"/>
           <p:nvPr/>
         </p:nvSpPr>
@@ -14540,7 +14617,7 @@
       </p:sp>
       <p:sp>
         <p:nvSpPr>
-          <p:cNvPr id="24" name="Text 20"/>
+          <p:cNvPr id="24" name="Text 19"/>
           <p:cNvSpPr txBox="1"/>
           <p:nvPr/>
         </p:nvSpPr>
@@ -14576,7 +14653,7 @@
       </p:sp>
       <p:sp>
         <p:nvSpPr>
-          <p:cNvPr id="25" name="Shape 21"/>
+          <p:cNvPr id="25" name="Shape 20"/>
           <p:cNvSpPr/>
           <p:nvPr/>
         </p:nvSpPr>
@@ -14600,7 +14677,7 @@
       </p:sp>
       <p:sp>
         <p:nvSpPr>
-          <p:cNvPr id="26" name="Shape 22"/>
+          <p:cNvPr id="26" name="Shape 21"/>
           <p:cNvSpPr/>
           <p:nvPr/>
         </p:nvSpPr>
@@ -14634,7 +14711,7 @@
       </p:sp>
       <p:sp>
         <p:nvSpPr>
-          <p:cNvPr id="27" name="Shape 23"/>
+          <p:cNvPr id="27" name="Shape 22"/>
           <p:cNvSpPr/>
           <p:nvPr/>
         </p:nvSpPr>
@@ -14659,14 +14736,14 @@
       </p:sp>
       <p:pic>
         <p:nvPicPr>
-          <p:cNvPr id="28" name="Image 2" descr="Liver illustration">    </p:cNvPr>
+          <p:cNvPr id="28" name="Image 3" descr="Liver illustration">    </p:cNvPr>
           <p:cNvPicPr>
             <a:picLocks noChangeAspect="1"/>
           </p:cNvPicPr>
           <p:nvPr/>
         </p:nvPicPr>
         <p:blipFill>
-          <a:blip r:embed="rId3"/>
+          <a:blip r:embed="rId4"/>
           <a:srcRect l="0" r="0" t="0" b="0"/>
           <a:stretch/>
         </p:blipFill>
@@ -14682,7 +14759,7 @@
       </p:pic>
       <p:sp>
         <p:nvSpPr>
-          <p:cNvPr id="29" name="Text 24"/>
+          <p:cNvPr id="29" name="Text 23"/>
           <p:cNvSpPr txBox="1"/>
           <p:nvPr/>
         </p:nvSpPr>
@@ -14718,7 +14795,7 @@
       </p:sp>
       <p:sp>
         <p:nvSpPr>
-          <p:cNvPr id="30" name="Text 25"/>
+          <p:cNvPr id="30" name="Text 24"/>
           <p:cNvSpPr txBox="1"/>
           <p:nvPr/>
         </p:nvSpPr>
@@ -14754,7 +14831,7 @@
       </p:sp>
       <p:sp>
         <p:nvSpPr>
-          <p:cNvPr id="31" name="Text 26"/>
+          <p:cNvPr id="31" name="Text 25"/>
           <p:cNvSpPr txBox="1"/>
           <p:nvPr/>
         </p:nvSpPr>
@@ -14790,7 +14867,7 @@
       </p:sp>
       <p:sp>
         <p:nvSpPr>
-          <p:cNvPr id="32" name="Text 27"/>
+          <p:cNvPr id="32" name="Text 26"/>
           <p:cNvSpPr txBox="1"/>
           <p:nvPr/>
         </p:nvSpPr>
@@ -15013,7 +15090,7 @@
         </p:nvSpPr>
         <p:spPr>
           <a:xfrm>
-            <a:off x="548640" y="1444752"/>
+            <a:off x="548640" y="1243584"/>
             <a:ext cx="5486400" cy="228600"/>
           </a:xfrm>
           <a:prstGeom prst="rect">
@@ -21558,12 +21635,12 @@
         </p:nvSpPr>
         <p:spPr>
           <a:xfrm>
-            <a:off x="548640" y="3813048"/>
-            <a:ext cx="1920240" cy="713232"/>
+            <a:off x="548640" y="3749040"/>
+            <a:ext cx="1874520" cy="822960"/>
           </a:xfrm>
           <a:prstGeom prst="roundRect">
             <a:avLst>
-              <a:gd name="adj" fmla="val 10256"/>
+              <a:gd name="adj" fmla="val 8889"/>
             </a:avLst>
           </a:prstGeom>
           <a:solidFill>
@@ -21585,8 +21662,8 @@
         </p:nvSpPr>
         <p:spPr>
           <a:xfrm>
-            <a:off x="658368" y="3840480"/>
-            <a:ext cx="868680" cy="658368"/>
+            <a:off x="548640" y="3785616"/>
+            <a:ext cx="1874520" cy="438912"/>
           </a:xfrm>
           <a:prstGeom prst="rect">
             <a:avLst/>
@@ -21598,18 +21675,18 @@
           <a:bodyPr wrap="square" lIns="0" tIns="0" rIns="0" bIns="0" rtlCol="0" anchor="ctr"/>
           <a:lstStyle/>
           <a:p>
-            <a:pPr indent="0" marL="0">
-              <a:buNone/>
-            </a:pPr>
-            <a:r>
-              <a:rPr lang="en-US" sz="2200" b="1" dirty="0">
+            <a:pPr algn="ctr" indent="0" marL="0">
+              <a:buNone/>
+            </a:pPr>
+            <a:r>
+              <a:rPr lang="en-US" sz="2400" b="1" dirty="0">
                 <a:solidFill>
                   <a:srgbClr val="E8A03C"/>
                 </a:solidFill>
               </a:rPr>
               <a:t>2 h</a:t>
             </a:r>
-            <a:endParaRPr lang="en-US" sz="2200" dirty="0"/>
+            <a:endParaRPr lang="en-US" sz="2400" dirty="0"/>
           </a:p>
         </p:txBody>
       </p:sp>
@@ -21621,20 +21698,20 @@
         </p:nvSpPr>
         <p:spPr>
           <a:xfrm>
-            <a:off x="1508760" y="3840480"/>
-            <a:ext cx="914400" cy="658368"/>
-          </a:xfrm>
-          <a:prstGeom prst="rect">
-            <a:avLst/>
-          </a:prstGeom>
-          <a:noFill/>
-          <a:ln/>
-        </p:spPr>
-        <p:txBody>
-          <a:bodyPr wrap="square" lIns="0" tIns="0" rIns="0" bIns="0" rtlCol="0" anchor="ctr"/>
-          <a:lstStyle/>
-          <a:p>
-            <a:pPr indent="0" marL="0">
+            <a:off x="640080" y="4224528"/>
+            <a:ext cx="1691640" cy="310896"/>
+          </a:xfrm>
+          <a:prstGeom prst="rect">
+            <a:avLst/>
+          </a:prstGeom>
+          <a:noFill/>
+          <a:ln/>
+        </p:spPr>
+        <p:txBody>
+          <a:bodyPr wrap="square" lIns="0" tIns="0" rIns="0" bIns="0" rtlCol="0" anchor="t"/>
+          <a:lstStyle/>
+          <a:p>
+            <a:pPr algn="ctr" indent="0" marL="0">
               <a:buNone/>
             </a:pPr>
             <a:r>
@@ -21643,7 +21720,7 @@
                   <a:srgbClr val="FFFFFF"/>
                 </a:solidFill>
               </a:rPr>
-              <a:t>glucose forecast, every 5 minutes</a:t>
+              <a:t>glucose forecast, every 5 min</a:t>
             </a:r>
             <a:endParaRPr lang="en-US" sz="1000" dirty="0"/>
           </a:p>
@@ -21657,12 +21734,12 @@
         </p:nvSpPr>
         <p:spPr>
           <a:xfrm>
-            <a:off x="2606040" y="3813048"/>
-            <a:ext cx="1920240" cy="713232"/>
+            <a:off x="2606040" y="3749040"/>
+            <a:ext cx="1874520" cy="822960"/>
           </a:xfrm>
           <a:prstGeom prst="roundRect">
             <a:avLst>
-              <a:gd name="adj" fmla="val 10256"/>
+              <a:gd name="adj" fmla="val 8889"/>
             </a:avLst>
           </a:prstGeom>
           <a:solidFill>
@@ -21684,8 +21761,8 @@
         </p:nvSpPr>
         <p:spPr>
           <a:xfrm>
-            <a:off x="2715768" y="3840480"/>
-            <a:ext cx="868680" cy="658368"/>
+            <a:off x="2606040" y="3785616"/>
+            <a:ext cx="1874520" cy="438912"/>
           </a:xfrm>
           <a:prstGeom prst="rect">
             <a:avLst/>
@@ -21697,18 +21774,18 @@
           <a:bodyPr wrap="square" lIns="0" tIns="0" rIns="0" bIns="0" rtlCol="0" anchor="ctr"/>
           <a:lstStyle/>
           <a:p>
-            <a:pPr indent="0" marL="0">
-              <a:buNone/>
-            </a:pPr>
-            <a:r>
-              <a:rPr lang="en-US" sz="2200" b="1" dirty="0">
+            <a:pPr algn="ctr" indent="0" marL="0">
+              <a:buNone/>
+            </a:pPr>
+            <a:r>
+              <a:rPr lang="en-US" sz="2400" b="1" dirty="0">
                 <a:solidFill>
                   <a:srgbClr val="E8A03C"/>
                 </a:solidFill>
               </a:rPr>
               <a:t>4</a:t>
             </a:r>
-            <a:endParaRPr lang="en-US" sz="2200" dirty="0"/>
+            <a:endParaRPr lang="en-US" sz="2400" dirty="0"/>
           </a:p>
         </p:txBody>
       </p:sp>
@@ -21720,20 +21797,20 @@
         </p:nvSpPr>
         <p:spPr>
           <a:xfrm>
-            <a:off x="3566160" y="3840480"/>
-            <a:ext cx="914400" cy="658368"/>
-          </a:xfrm>
-          <a:prstGeom prst="rect">
-            <a:avLst/>
-          </a:prstGeom>
-          <a:noFill/>
-          <a:ln/>
-        </p:spPr>
-        <p:txBody>
-          <a:bodyPr wrap="square" lIns="0" tIns="0" rIns="0" bIns="0" rtlCol="0" anchor="ctr"/>
-          <a:lstStyle/>
-          <a:p>
-            <a:pPr indent="0" marL="0">
+            <a:off x="2697480" y="4224528"/>
+            <a:ext cx="1691640" cy="310896"/>
+          </a:xfrm>
+          <a:prstGeom prst="rect">
+            <a:avLst/>
+          </a:prstGeom>
+          <a:noFill/>
+          <a:ln/>
+        </p:spPr>
+        <p:txBody>
+          <a:bodyPr wrap="square" lIns="0" tIns="0" rIns="0" bIns="0" rtlCol="0" anchor="t"/>
+          <a:lstStyle/>
+          <a:p>
+            <a:pPr algn="ctr" indent="0" marL="0">
               <a:buNone/>
             </a:pPr>
             <a:r>
@@ -21742,7 +21819,7 @@
                   <a:srgbClr val="FFFFFF"/>
                 </a:solidFill>
               </a:rPr>
-              <a:t>organ modules: glucose, liver, eye, kidney</a:t>
+              <a:t>glucose, liver, eye, kidney</a:t>
             </a:r>
             <a:endParaRPr lang="en-US" sz="1000" dirty="0"/>
           </a:p>
@@ -21756,12 +21833,12 @@
         </p:nvSpPr>
         <p:spPr>
           <a:xfrm>
-            <a:off x="4663440" y="3813048"/>
-            <a:ext cx="1920240" cy="713232"/>
+            <a:off x="4663440" y="3749040"/>
+            <a:ext cx="1874520" cy="822960"/>
           </a:xfrm>
           <a:prstGeom prst="roundRect">
             <a:avLst>
-              <a:gd name="adj" fmla="val 10256"/>
+              <a:gd name="adj" fmla="val 8889"/>
             </a:avLst>
           </a:prstGeom>
           <a:solidFill>
@@ -21783,8 +21860,8 @@
         </p:nvSpPr>
         <p:spPr>
           <a:xfrm>
-            <a:off x="4773168" y="3840480"/>
-            <a:ext cx="868680" cy="658368"/>
+            <a:off x="4663440" y="3785616"/>
+            <a:ext cx="1874520" cy="438912"/>
           </a:xfrm>
           <a:prstGeom prst="rect">
             <a:avLst/>
@@ -21796,18 +21873,18 @@
           <a:bodyPr wrap="square" lIns="0" tIns="0" rIns="0" bIns="0" rtlCol="0" anchor="ctr"/>
           <a:lstStyle/>
           <a:p>
-            <a:pPr indent="0" marL="0">
-              <a:buNone/>
-            </a:pPr>
-            <a:r>
-              <a:rPr lang="en-US" sz="2200" b="1" dirty="0">
+            <a:pPr algn="ctr" indent="0" marL="0">
+              <a:buNone/>
+            </a:pPr>
+            <a:r>
+              <a:rPr lang="en-US" sz="2400" b="1" dirty="0">
                 <a:solidFill>
                   <a:srgbClr val="E8A03C"/>
                 </a:solidFill>
               </a:rPr>
               <a:t>~1 ms</a:t>
             </a:r>
-            <a:endParaRPr lang="en-US" sz="2200" dirty="0"/>
+            <a:endParaRPr lang="en-US" sz="2400" dirty="0"/>
           </a:p>
         </p:txBody>
       </p:sp>
@@ -21819,20 +21896,20 @@
         </p:nvSpPr>
         <p:spPr>
           <a:xfrm>
-            <a:off x="5623560" y="3840480"/>
-            <a:ext cx="914400" cy="658368"/>
-          </a:xfrm>
-          <a:prstGeom prst="rect">
-            <a:avLst/>
-          </a:prstGeom>
-          <a:noFill/>
-          <a:ln/>
-        </p:spPr>
-        <p:txBody>
-          <a:bodyPr wrap="square" lIns="0" tIns="0" rIns="0" bIns="0" rtlCol="0" anchor="ctr"/>
-          <a:lstStyle/>
-          <a:p>
-            <a:pPr indent="0" marL="0">
+            <a:off x="4754880" y="4224528"/>
+            <a:ext cx="1691640" cy="310896"/>
+          </a:xfrm>
+          <a:prstGeom prst="rect">
+            <a:avLst/>
+          </a:prstGeom>
+          <a:noFill/>
+          <a:ln/>
+        </p:spPr>
+        <p:txBody>
+          <a:bodyPr wrap="square" lIns="0" tIns="0" rIns="0" bIns="0" rtlCol="0" anchor="t"/>
+          <a:lstStyle/>
+          <a:p>
+            <a:pPr algn="ctr" indent="0" marL="0">
               <a:buNone/>
             </a:pPr>
             <a:r>
@@ -21841,7 +21918,7 @@
                   <a:srgbClr val="FFFFFF"/>
                 </a:solidFill>
               </a:rPr>
-              <a:t>per reading, runs without a GPU</a:t>
+              <a:t>per reading, no GPU needed</a:t>
             </a:r>
             <a:endParaRPr lang="en-US" sz="1000" dirty="0"/>
           </a:p>
@@ -21855,12 +21932,12 @@
         </p:nvSpPr>
         <p:spPr>
           <a:xfrm>
-            <a:off x="6720840" y="3813048"/>
-            <a:ext cx="1920240" cy="713232"/>
+            <a:off x="6720840" y="3749040"/>
+            <a:ext cx="1874520" cy="822960"/>
           </a:xfrm>
           <a:prstGeom prst="roundRect">
             <a:avLst>
-              <a:gd name="adj" fmla="val 10256"/>
+              <a:gd name="adj" fmla="val 8889"/>
             </a:avLst>
           </a:prstGeom>
           <a:solidFill>
@@ -21882,8 +21959,8 @@
         </p:nvSpPr>
         <p:spPr>
           <a:xfrm>
-            <a:off x="6830568" y="3840480"/>
-            <a:ext cx="868680" cy="658368"/>
+            <a:off x="6720840" y="3785616"/>
+            <a:ext cx="1874520" cy="438912"/>
           </a:xfrm>
           <a:prstGeom prst="rect">
             <a:avLst/>
@@ -21895,18 +21972,18 @@
           <a:bodyPr wrap="square" lIns="0" tIns="0" rIns="0" bIns="0" rtlCol="0" anchor="ctr"/>
           <a:lstStyle/>
           <a:p>
-            <a:pPr indent="0" marL="0">
-              <a:buNone/>
-            </a:pPr>
-            <a:r>
-              <a:rPr lang="en-US" sz="2200" b="1" dirty="0">
+            <a:pPr algn="ctr" indent="0" marL="0">
+              <a:buNone/>
+            </a:pPr>
+            <a:r>
+              <a:rPr lang="en-US" sz="2400" b="1" dirty="0">
                 <a:solidFill>
                   <a:srgbClr val="E8A03C"/>
                 </a:solidFill>
               </a:rPr>
               <a:t>3</a:t>
             </a:r>
-            <a:endParaRPr lang="en-US" sz="2200" dirty="0"/>
+            <a:endParaRPr lang="en-US" sz="2400" dirty="0"/>
           </a:p>
         </p:txBody>
       </p:sp>
@@ -21918,20 +21995,20 @@
         </p:nvSpPr>
         <p:spPr>
           <a:xfrm>
-            <a:off x="7680960" y="3840480"/>
-            <a:ext cx="914400" cy="658368"/>
-          </a:xfrm>
-          <a:prstGeom prst="rect">
-            <a:avLst/>
-          </a:prstGeom>
-          <a:noFill/>
-          <a:ln/>
-        </p:spPr>
-        <p:txBody>
-          <a:bodyPr wrap="square" lIns="0" tIns="0" rIns="0" bIns="0" rtlCol="0" anchor="ctr"/>
-          <a:lstStyle/>
-          <a:p>
-            <a:pPr indent="0" marL="0">
+            <a:off x="6812280" y="4224528"/>
+            <a:ext cx="1691640" cy="310896"/>
+          </a:xfrm>
+          <a:prstGeom prst="rect">
+            <a:avLst/>
+          </a:prstGeom>
+          <a:noFill/>
+          <a:ln/>
+        </p:spPr>
+        <p:txBody>
+          <a:bodyPr wrap="square" lIns="0" tIns="0" rIns="0" bIns="0" rtlCol="0" anchor="t"/>
+          <a:lstStyle/>
+          <a:p>
+            <a:pPr algn="ctr" indent="0" marL="0">
               <a:buNone/>
             </a:pPr>
             <a:r>

</xml_diff>

<commit_message>
Bring the README, slides, diagram and speaker script in line with the reworked Heart watch results
The detailed Heart watch table in the README, the architecture footnote, the presentation PDF, PowerPoint slide 14 and the speaker script quoted the earlier numbers. They now match results/cardio_metrics.json (AUROC 0.82, 71% of events caught, median 22 hours of warning). The diagram and presentation scripts read the numbers from the results file.
</commit_message>
<xml_diff>
--- a/Kaya_IIT-Hyderabad/docs/Kaya_pitch_deck.pptx
+++ b/Kaya_IIT-Hyderabad/docs/Kaya_pitch_deck.pptx
@@ -6448,6 +6448,336 @@
 </file>
 
 <file path=ppt/slides/slide14.xml><?xml version="1.0" encoding="utf-8"?>
+<p:sld xmlns:a="http://schemas.openxmlformats.org/drawingml/2006/main" xmlns:p="http://schemas.openxmlformats.org/presentationml/2006/main" xmlns:r="http://schemas.openxmlformats.org/officeDocument/2006/relationships">
+  <p:cSld>
+    <p:spTree>
+      <p:nvGrpSpPr>
+        <p:cNvPr id="1" name=""/>
+        <p:cNvGrpSpPr/>
+        <p:nvPr/>
+      </p:nvGrpSpPr>
+      <p:grpSpPr/>
+      <p:sp>
+        <p:nvSpPr>
+          <p:cNvPr id="2" name="Eyebrow"/>
+          <p:cNvSpPr txBox="1"/>
+          <p:nvPr/>
+        </p:nvSpPr>
+        <p:spPr>
+          <a:xfrm>
+            <a:off x="548640" y="347472"/>
+            <a:ext cx="8046720" cy="228600"/>
+          </a:xfrm>
+          <a:prstGeom prst="rect">
+            <a:avLst/>
+          </a:prstGeom>
+          <a:noFill/>
+        </p:spPr>
+        <p:txBody>
+          <a:bodyPr wrap="square" lIns="0" rIns="0" tIns="0" bIns="0">
+            <a:spAutoFit/>
+          </a:bodyPr>
+          <a:lstStyle/>
+          <a:p>
+            <a:r>
+              <a:rPr sz="1100" b="1">
+                <a:solidFill>
+                  <a:srgbClr val="0F7068"/>
+                </a:solidFill>
+              </a:rPr>
+              <a:t>THE AI / ML MODELS  ·  TWO STREAMS FUSED</a:t>
+            </a:r>
+          </a:p>
+        </p:txBody>
+      </p:sp>
+      <p:sp>
+        <p:nvSpPr>
+          <p:cNvPr id="3" name="Title"/>
+          <p:cNvSpPr txBox="1"/>
+          <p:nvPr/>
+        </p:nvSpPr>
+        <p:spPr>
+          <a:xfrm>
+            <a:off x="548640" y="603504"/>
+            <a:ext cx="8046720" cy="548640"/>
+          </a:xfrm>
+          <a:prstGeom prst="rect">
+            <a:avLst/>
+          </a:prstGeom>
+          <a:noFill/>
+        </p:spPr>
+        <p:txBody>
+          <a:bodyPr wrap="square" lIns="0" rIns="0" tIns="0" bIns="0">
+            <a:spAutoFit/>
+          </a:bodyPr>
+          <a:lstStyle/>
+          <a:p>
+            <a:r>
+              <a:rPr sz="2500" b="1">
+                <a:solidFill>
+                  <a:srgbClr val="0F3B38"/>
+                </a:solidFill>
+              </a:rPr>
+              <a:t>The Heart watch: a week of nights, read with the record</a:t>
+            </a:r>
+          </a:p>
+        </p:txBody>
+      </p:sp>
+      <p:sp>
+        <p:nvSpPr>
+          <p:cNvPr id="4" name="Rounded Rectangle 3"/>
+          <p:cNvSpPr/>
+          <p:nvPr/>
+        </p:nvSpPr>
+        <p:spPr>
+          <a:xfrm>
+            <a:off x="548640" y="1325880"/>
+            <a:ext cx="4480560" cy="3200400"/>
+          </a:xfrm>
+          <a:prstGeom prst="roundRect">
+            <a:avLst>
+              <a:gd name="adj" fmla="val 4000"/>
+            </a:avLst>
+          </a:prstGeom>
+          <a:solidFill>
+            <a:srgbClr val="FAF9F5"/>
+          </a:solidFill>
+          <a:ln w="9525">
+            <a:solidFill>
+              <a:srgbClr val="E4E1D8"/>
+            </a:solidFill>
+          </a:ln>
+          <a:effectLst/>
+        </p:spPr>
+        <p:style>
+          <a:lnRef idx="1">
+            <a:schemeClr val="accent1"/>
+          </a:lnRef>
+          <a:fillRef idx="3">
+            <a:schemeClr val="accent1"/>
+          </a:fillRef>
+          <a:effectRef idx="2">
+            <a:schemeClr val="accent1"/>
+          </a:effectRef>
+          <a:fontRef idx="minor">
+            <a:schemeClr val="lt1"/>
+          </a:fontRef>
+        </p:style>
+        <p:txBody>
+          <a:bodyPr rtlCol="0" anchor="ctr"/>
+          <a:lstStyle/>
+          <a:p>
+            <a:pPr algn="ctr"/>
+          </a:p>
+        </p:txBody>
+      </p:sp>
+      <p:pic>
+        <p:nvPicPr>
+          <p:cNvPr id="5" name="Picture 4" descr="heart_crop.png"/>
+          <p:cNvPicPr>
+            <a:picLocks noChangeAspect="1"/>
+          </p:cNvPicPr>
+          <p:nvPr/>
+        </p:nvPicPr>
+        <p:blipFill>
+          <a:blip r:embed="rId2"/>
+          <a:stretch>
+            <a:fillRect/>
+          </a:stretch>
+        </p:blipFill>
+        <p:spPr>
+          <a:xfrm>
+            <a:off x="1189634" y="1417320"/>
+            <a:ext cx="3198571" cy="3017520"/>
+          </a:xfrm>
+          <a:prstGeom prst="rect">
+            <a:avLst/>
+          </a:prstGeom>
+        </p:spPr>
+      </p:pic>
+      <p:sp>
+        <p:nvSpPr>
+          <p:cNvPr id="6" name="Rounded Rectangle 5"/>
+          <p:cNvSpPr/>
+          <p:nvPr/>
+        </p:nvSpPr>
+        <p:spPr>
+          <a:xfrm>
+            <a:off x="5212080" y="1325880"/>
+            <a:ext cx="3383280" cy="3200400"/>
+          </a:xfrm>
+          <a:prstGeom prst="roundRect">
+            <a:avLst>
+              <a:gd name="adj" fmla="val 4000"/>
+            </a:avLst>
+          </a:prstGeom>
+          <a:solidFill>
+            <a:srgbClr val="FAF9F5"/>
+          </a:solidFill>
+          <a:ln w="9525">
+            <a:solidFill>
+              <a:srgbClr val="E4E1D8"/>
+            </a:solidFill>
+          </a:ln>
+          <a:effectLst/>
+        </p:spPr>
+        <p:style>
+          <a:lnRef idx="1">
+            <a:schemeClr val="accent1"/>
+          </a:lnRef>
+          <a:fillRef idx="3">
+            <a:schemeClr val="accent1"/>
+          </a:fillRef>
+          <a:effectRef idx="2">
+            <a:schemeClr val="accent1"/>
+          </a:effectRef>
+          <a:fontRef idx="minor">
+            <a:schemeClr val="lt1"/>
+          </a:fontRef>
+        </p:style>
+        <p:txBody>
+          <a:bodyPr rtlCol="0" anchor="ctr"/>
+          <a:lstStyle/>
+          <a:p>
+            <a:pPr algn="ctr"/>
+          </a:p>
+        </p:txBody>
+      </p:sp>
+      <p:sp>
+        <p:nvSpPr>
+          <p:cNvPr id="7" name="TextBox 6"/>
+          <p:cNvSpPr txBox="1"/>
+          <p:nvPr/>
+        </p:nvSpPr>
+        <p:spPr>
+          <a:xfrm>
+            <a:off x="5394960" y="1463040"/>
+            <a:ext cx="3017520" cy="274320"/>
+          </a:xfrm>
+          <a:prstGeom prst="rect">
+            <a:avLst/>
+          </a:prstGeom>
+          <a:noFill/>
+        </p:spPr>
+        <p:txBody>
+          <a:bodyPr wrap="square" lIns="0" rIns="0" tIns="0" bIns="0">
+            <a:spAutoFit/>
+          </a:bodyPr>
+          <a:lstStyle/>
+          <a:p>
+            <a:r>
+              <a:rPr sz="1200" b="1">
+                <a:solidFill>
+                  <a:srgbClr val="0F3B38"/>
+                </a:solidFill>
+              </a:rPr>
+              <a:t>What the fusion study measured</a:t>
+            </a:r>
+          </a:p>
+        </p:txBody>
+      </p:sp>
+      <p:sp>
+        <p:nvSpPr>
+          <p:cNvPr id="8" name="TextBox 7"/>
+          <p:cNvSpPr txBox="1"/>
+          <p:nvPr/>
+        </p:nvSpPr>
+        <p:spPr>
+          <a:xfrm>
+            <a:off x="5394960" y="1783080"/>
+            <a:ext cx="3017520" cy="2651760"/>
+          </a:xfrm>
+          <a:prstGeom prst="rect">
+            <a:avLst/>
+          </a:prstGeom>
+          <a:noFill/>
+        </p:spPr>
+        <p:txBody>
+          <a:bodyPr wrap="square" lIns="0" rIns="0" tIns="0" bIns="0">
+            <a:spAutoFit/>
+          </a:bodyPr>
+          <a:lstStyle/>
+          <a:p>
+            <a:r>
+              <a:rPr sz="1000" b="0">
+                <a:solidFill>
+                  <a:srgbClr val="5B6B77"/>
+                </a:solidFill>
+              </a:rPr>
+              <a:t>Wearable week (sleep, HRV, heart rate) plus the record flag a cardiovascular event up to 72 hours ahead.</a:t>
+            </a:r>
+          </a:p>
+          <a:p>
+            <a:pPr>
+              <a:spcBef>
+                <a:spcPts val="500"/>
+              </a:spcBef>
+            </a:pPr>
+            <a:r>
+              <a:rPr sz="1000" b="0">
+                <a:solidFill>
+                  <a:srgbClr val="5B6B77"/>
+                </a:solidFill>
+              </a:rPr>
+              <a:t>AUROC 0.82. Wearable alone 0.80; record alone 0.69; simple clinical rule 0.68.</a:t>
+            </a:r>
+          </a:p>
+          <a:p>
+            <a:pPr>
+              <a:spcBef>
+                <a:spcPts val="500"/>
+              </a:spcBef>
+            </a:pPr>
+            <a:r>
+              <a:rPr sz="1000" b="0">
+                <a:solidFill>
+                  <a:srgbClr val="5B6B77"/>
+                </a:solidFill>
+              </a:rPr>
+              <a:t>71% of events caught, a median 22 hours early, at about 1 false alert per patient-month.</a:t>
+            </a:r>
+          </a:p>
+          <a:p>
+            <a:pPr>
+              <a:spcBef>
+                <a:spcPts val="500"/>
+              </a:spcBef>
+            </a:pPr>
+            <a:r>
+              <a:rPr sz="1000" b="0">
+                <a:solidFill>
+                  <a:srgbClr val="5B6B77"/>
+                </a:solidFill>
+              </a:rPr>
+              <a:t>For glucose, medicines lift low-glucose AUROC from 0.85 to 0.95; HRV and sleep add little.</a:t>
+            </a:r>
+          </a:p>
+          <a:p>
+            <a:pPr>
+              <a:spcBef>
+                <a:spcPts val="500"/>
+              </a:spcBef>
+            </a:pPr>
+            <a:r>
+              <a:rPr sz="1000" b="0">
+                <a:solidFill>
+                  <a:srgbClr val="5B6B77"/>
+                </a:solidFill>
+              </a:rPr>
+              <a:t>Synthetic data with assumed couplings: it shows the fusion works, not clinical accuracy.</a:t>
+            </a:r>
+          </a:p>
+        </p:txBody>
+      </p:sp>
+    </p:spTree>
+  </p:cSld>
+  <p:clrMapOvr>
+    <a:masterClrMapping/>
+  </p:clrMapOvr>
+</p:sld>
+</file>
+
+<file path=ppt/slides/slide15.xml><?xml version="1.0" encoding="utf-8"?>
 <p:sld xmlns:a="http://schemas.openxmlformats.org/drawingml/2006/main" xmlns:r="http://schemas.openxmlformats.org/officeDocument/2006/relationships" xmlns:p="http://schemas.openxmlformats.org/presentationml/2006/main">
   <p:cSld name="Slide 14">
     <p:spTree>
@@ -9200,7 +9530,7 @@
 </p:sld>
 </file>
 
-<file path=ppt/slides/slide15.xml><?xml version="1.0" encoding="utf-8"?>
+<file path=ppt/slides/slide16.xml><?xml version="1.0" encoding="utf-8"?>
 <p:sld xmlns:a="http://schemas.openxmlformats.org/drawingml/2006/main" xmlns:r="http://schemas.openxmlformats.org/officeDocument/2006/relationships" xmlns:p="http://schemas.openxmlformats.org/presentationml/2006/main">
   <p:cSld name="Slide 15">
     <p:spTree>
@@ -10206,7 +10536,7 @@
 </p:sld>
 </file>
 
-<file path=ppt/slides/slide16.xml><?xml version="1.0" encoding="utf-8"?>
+<file path=ppt/slides/slide17.xml><?xml version="1.0" encoding="utf-8"?>
 <p:sld xmlns:a="http://schemas.openxmlformats.org/drawingml/2006/main" xmlns:r="http://schemas.openxmlformats.org/officeDocument/2006/relationships" xmlns:p="http://schemas.openxmlformats.org/presentationml/2006/main">
   <p:cSld name="Slide 16">
     <p:spTree>
@@ -11032,7 +11362,7 @@
 </p:sld>
 </file>
 
-<file path=ppt/slides/slide17.xml><?xml version="1.0" encoding="utf-8"?>
+<file path=ppt/slides/slide18.xml><?xml version="1.0" encoding="utf-8"?>
 <p:sld xmlns:a="http://schemas.openxmlformats.org/drawingml/2006/main" xmlns:r="http://schemas.openxmlformats.org/officeDocument/2006/relationships" xmlns:p="http://schemas.openxmlformats.org/presentationml/2006/main">
   <p:cSld name="Slide 17">
     <p:spTree>
@@ -11240,7 +11570,7 @@
 </p:sld>
 </file>
 
-<file path=ppt/slides/slide18.xml><?xml version="1.0" encoding="utf-8"?>
+<file path=ppt/slides/slide19.xml><?xml version="1.0" encoding="utf-8"?>
 <p:sld xmlns:a="http://schemas.openxmlformats.org/drawingml/2006/main" xmlns:r="http://schemas.openxmlformats.org/officeDocument/2006/relationships" xmlns:p="http://schemas.openxmlformats.org/presentationml/2006/main">
   <p:cSld name="Slide 18">
     <p:bg>
@@ -11295,336 +11625,6 @@
           </a:prstGeom>
         </p:spPr>
       </p:pic>
-    </p:spTree>
-  </p:cSld>
-  <p:clrMapOvr>
-    <a:masterClrMapping/>
-  </p:clrMapOvr>
-</p:sld>
-</file>
-
-<file path=ppt/slides/slide19.xml><?xml version="1.0" encoding="utf-8"?>
-<p:sld xmlns:a="http://schemas.openxmlformats.org/drawingml/2006/main" xmlns:p="http://schemas.openxmlformats.org/presentationml/2006/main" xmlns:r="http://schemas.openxmlformats.org/officeDocument/2006/relationships">
-  <p:cSld>
-    <p:spTree>
-      <p:nvGrpSpPr>
-        <p:cNvPr id="1" name=""/>
-        <p:cNvGrpSpPr/>
-        <p:nvPr/>
-      </p:nvGrpSpPr>
-      <p:grpSpPr/>
-      <p:sp>
-        <p:nvSpPr>
-          <p:cNvPr id="2" name="Eyebrow"/>
-          <p:cNvSpPr txBox="1"/>
-          <p:nvPr/>
-        </p:nvSpPr>
-        <p:spPr>
-          <a:xfrm>
-            <a:off x="548640" y="347472"/>
-            <a:ext cx="8046720" cy="228600"/>
-          </a:xfrm>
-          <a:prstGeom prst="rect">
-            <a:avLst/>
-          </a:prstGeom>
-          <a:noFill/>
-        </p:spPr>
-        <p:txBody>
-          <a:bodyPr wrap="square" lIns="0" rIns="0" tIns="0" bIns="0">
-            <a:spAutoFit/>
-          </a:bodyPr>
-          <a:lstStyle/>
-          <a:p>
-            <a:r>
-              <a:rPr sz="1100" b="1">
-                <a:solidFill>
-                  <a:srgbClr val="0F7068"/>
-                </a:solidFill>
-              </a:rPr>
-              <a:t>THE AI / ML MODELS  ·  TWO STREAMS FUSED</a:t>
-            </a:r>
-          </a:p>
-        </p:txBody>
-      </p:sp>
-      <p:sp>
-        <p:nvSpPr>
-          <p:cNvPr id="3" name="Title"/>
-          <p:cNvSpPr txBox="1"/>
-          <p:nvPr/>
-        </p:nvSpPr>
-        <p:spPr>
-          <a:xfrm>
-            <a:off x="548640" y="603504"/>
-            <a:ext cx="8046720" cy="548640"/>
-          </a:xfrm>
-          <a:prstGeom prst="rect">
-            <a:avLst/>
-          </a:prstGeom>
-          <a:noFill/>
-        </p:spPr>
-        <p:txBody>
-          <a:bodyPr wrap="square" lIns="0" rIns="0" tIns="0" bIns="0">
-            <a:spAutoFit/>
-          </a:bodyPr>
-          <a:lstStyle/>
-          <a:p>
-            <a:r>
-              <a:rPr sz="2500" b="1">
-                <a:solidFill>
-                  <a:srgbClr val="0F3B38"/>
-                </a:solidFill>
-              </a:rPr>
-              <a:t>The Heart watch: a week of nights, read with the record</a:t>
-            </a:r>
-          </a:p>
-        </p:txBody>
-      </p:sp>
-      <p:sp>
-        <p:nvSpPr>
-          <p:cNvPr id="4" name="Rounded Rectangle 3"/>
-          <p:cNvSpPr/>
-          <p:nvPr/>
-        </p:nvSpPr>
-        <p:spPr>
-          <a:xfrm>
-            <a:off x="548640" y="1325880"/>
-            <a:ext cx="4480560" cy="3200400"/>
-          </a:xfrm>
-          <a:prstGeom prst="roundRect">
-            <a:avLst>
-              <a:gd name="adj" fmla="val 4000"/>
-            </a:avLst>
-          </a:prstGeom>
-          <a:solidFill>
-            <a:srgbClr val="FAF9F5"/>
-          </a:solidFill>
-          <a:ln w="9525">
-            <a:solidFill>
-              <a:srgbClr val="E4E1D8"/>
-            </a:solidFill>
-          </a:ln>
-          <a:effectLst/>
-        </p:spPr>
-        <p:style>
-          <a:lnRef idx="1">
-            <a:schemeClr val="accent1"/>
-          </a:lnRef>
-          <a:fillRef idx="3">
-            <a:schemeClr val="accent1"/>
-          </a:fillRef>
-          <a:effectRef idx="2">
-            <a:schemeClr val="accent1"/>
-          </a:effectRef>
-          <a:fontRef idx="minor">
-            <a:schemeClr val="lt1"/>
-          </a:fontRef>
-        </p:style>
-        <p:txBody>
-          <a:bodyPr rtlCol="0" anchor="ctr"/>
-          <a:lstStyle/>
-          <a:p>
-            <a:pPr algn="ctr"/>
-          </a:p>
-        </p:txBody>
-      </p:sp>
-      <p:pic>
-        <p:nvPicPr>
-          <p:cNvPr id="5" name="Picture 4" descr="heart_crop.png"/>
-          <p:cNvPicPr>
-            <a:picLocks noChangeAspect="1"/>
-          </p:cNvPicPr>
-          <p:nvPr/>
-        </p:nvPicPr>
-        <p:blipFill>
-          <a:blip r:embed="rId2"/>
-          <a:stretch>
-            <a:fillRect/>
-          </a:stretch>
-        </p:blipFill>
-        <p:spPr>
-          <a:xfrm>
-            <a:off x="1189634" y="1417320"/>
-            <a:ext cx="3198571" cy="3017520"/>
-          </a:xfrm>
-          <a:prstGeom prst="rect">
-            <a:avLst/>
-          </a:prstGeom>
-        </p:spPr>
-      </p:pic>
-      <p:sp>
-        <p:nvSpPr>
-          <p:cNvPr id="6" name="Rounded Rectangle 5"/>
-          <p:cNvSpPr/>
-          <p:nvPr/>
-        </p:nvSpPr>
-        <p:spPr>
-          <a:xfrm>
-            <a:off x="5212080" y="1325880"/>
-            <a:ext cx="3383280" cy="3200400"/>
-          </a:xfrm>
-          <a:prstGeom prst="roundRect">
-            <a:avLst>
-              <a:gd name="adj" fmla="val 4000"/>
-            </a:avLst>
-          </a:prstGeom>
-          <a:solidFill>
-            <a:srgbClr val="FAF9F5"/>
-          </a:solidFill>
-          <a:ln w="9525">
-            <a:solidFill>
-              <a:srgbClr val="E4E1D8"/>
-            </a:solidFill>
-          </a:ln>
-          <a:effectLst/>
-        </p:spPr>
-        <p:style>
-          <a:lnRef idx="1">
-            <a:schemeClr val="accent1"/>
-          </a:lnRef>
-          <a:fillRef idx="3">
-            <a:schemeClr val="accent1"/>
-          </a:fillRef>
-          <a:effectRef idx="2">
-            <a:schemeClr val="accent1"/>
-          </a:effectRef>
-          <a:fontRef idx="minor">
-            <a:schemeClr val="lt1"/>
-          </a:fontRef>
-        </p:style>
-        <p:txBody>
-          <a:bodyPr rtlCol="0" anchor="ctr"/>
-          <a:lstStyle/>
-          <a:p>
-            <a:pPr algn="ctr"/>
-          </a:p>
-        </p:txBody>
-      </p:sp>
-      <p:sp>
-        <p:nvSpPr>
-          <p:cNvPr id="7" name="TextBox 6"/>
-          <p:cNvSpPr txBox="1"/>
-          <p:nvPr/>
-        </p:nvSpPr>
-        <p:spPr>
-          <a:xfrm>
-            <a:off x="5394960" y="1463040"/>
-            <a:ext cx="3017520" cy="274320"/>
-          </a:xfrm>
-          <a:prstGeom prst="rect">
-            <a:avLst/>
-          </a:prstGeom>
-          <a:noFill/>
-        </p:spPr>
-        <p:txBody>
-          <a:bodyPr wrap="square" lIns="0" rIns="0" tIns="0" bIns="0">
-            <a:spAutoFit/>
-          </a:bodyPr>
-          <a:lstStyle/>
-          <a:p>
-            <a:r>
-              <a:rPr sz="1200" b="1">
-                <a:solidFill>
-                  <a:srgbClr val="0F3B38"/>
-                </a:solidFill>
-              </a:rPr>
-              <a:t>What the fusion study measured</a:t>
-            </a:r>
-          </a:p>
-        </p:txBody>
-      </p:sp>
-      <p:sp>
-        <p:nvSpPr>
-          <p:cNvPr id="8" name="TextBox 7"/>
-          <p:cNvSpPr txBox="1"/>
-          <p:nvPr/>
-        </p:nvSpPr>
-        <p:spPr>
-          <a:xfrm>
-            <a:off x="5394960" y="1783080"/>
-            <a:ext cx="3017520" cy="2651760"/>
-          </a:xfrm>
-          <a:prstGeom prst="rect">
-            <a:avLst/>
-          </a:prstGeom>
-          <a:noFill/>
-        </p:spPr>
-        <p:txBody>
-          <a:bodyPr wrap="square" lIns="0" rIns="0" tIns="0" bIns="0">
-            <a:spAutoFit/>
-          </a:bodyPr>
-          <a:lstStyle/>
-          <a:p>
-            <a:r>
-              <a:rPr sz="1000" b="0">
-                <a:solidFill>
-                  <a:srgbClr val="5B6B77"/>
-                </a:solidFill>
-              </a:rPr>
-              <a:t>Wearable week (sleep, HRV, heart rate) plus the record flag a cardiovascular event up to 72 hours ahead.</a:t>
-            </a:r>
-          </a:p>
-          <a:p>
-            <a:pPr>
-              <a:spcBef>
-                <a:spcPts val="500"/>
-              </a:spcBef>
-            </a:pPr>
-            <a:r>
-              <a:rPr sz="1000" b="0">
-                <a:solidFill>
-                  <a:srgbClr val="5B6B77"/>
-                </a:solidFill>
-              </a:rPr>
-              <a:t>AUROC 0.83. Wearable alone 0.82; record alone 0.69; simple clinical rule 0.69.</a:t>
-            </a:r>
-          </a:p>
-          <a:p>
-            <a:pPr>
-              <a:spcBef>
-                <a:spcPts val="500"/>
-              </a:spcBef>
-            </a:pPr>
-            <a:r>
-              <a:rPr sz="1000" b="0">
-                <a:solidFill>
-                  <a:srgbClr val="5B6B77"/>
-                </a:solidFill>
-              </a:rPr>
-              <a:t>76% of events caught, a median 23 hours early, at about 1 false alert per patient-month.</a:t>
-            </a:r>
-          </a:p>
-          <a:p>
-            <a:pPr>
-              <a:spcBef>
-                <a:spcPts val="500"/>
-              </a:spcBef>
-            </a:pPr>
-            <a:r>
-              <a:rPr sz="1000" b="0">
-                <a:solidFill>
-                  <a:srgbClr val="5B6B77"/>
-                </a:solidFill>
-              </a:rPr>
-              <a:t>For glucose, medicines lift low-glucose AUROC from 0.85 to 0.95; HRV and sleep add little.</a:t>
-            </a:r>
-          </a:p>
-          <a:p>
-            <a:pPr>
-              <a:spcBef>
-                <a:spcPts val="500"/>
-              </a:spcBef>
-            </a:pPr>
-            <a:r>
-              <a:rPr sz="1000" b="0">
-                <a:solidFill>
-                  <a:srgbClr val="5B6B77"/>
-                </a:solidFill>
-              </a:rPr>
-              <a:t>Synthetic data with assumed couplings: it shows the fusion works, not clinical accuracy.</a:t>
-            </a:r>
-          </a:p>
-        </p:txBody>
-      </p:sp>
     </p:spTree>
   </p:cSld>
   <p:clrMapOvr>

</xml_diff>

<commit_message>
Retake the README and slide screenshots from the final interface
Retakes the doctor workspace, Heart watch, record tabs, admin page and patient app screens (including Hindi, Telugu and Kannada), regenerates the presentation PDF and updates the picture on PowerPoint slide 14.
</commit_message>
<xml_diff>
--- a/Kaya_IIT-Hyderabad/docs/Kaya_pitch_deck.pptx
+++ b/Kaya_IIT-Hyderabad/docs/Kaya_pitch_deck.pptx
@@ -6571,30 +6571,6 @@
           </a:p>
         </p:txBody>
       </p:sp>
-      <p:pic>
-        <p:nvPicPr>
-          <p:cNvPr id="5" name="Picture 4" descr="heart_crop.png"/>
-          <p:cNvPicPr>
-            <a:picLocks noChangeAspect="1"/>
-          </p:cNvPicPr>
-          <p:nvPr/>
-        </p:nvPicPr>
-        <p:blipFill>
-          <a:blip r:embed="rId2"/>
-          <a:stretch>
-            <a:fillRect/>
-          </a:stretch>
-        </p:blipFill>
-        <p:spPr>
-          <a:xfrm>
-            <a:off x="1189634" y="1417320"/>
-            <a:ext cx="3198571" cy="3017520"/>
-          </a:xfrm>
-          <a:prstGeom prst="rect">
-            <a:avLst/>
-          </a:prstGeom>
-        </p:spPr>
-      </p:pic>
       <p:sp>
         <p:nvSpPr>
           <p:cNvPr id="6" name="Rounded Rectangle 5"/>
@@ -6769,6 +6745,30 @@
           </a:p>
         </p:txBody>
       </p:sp>
+      <p:pic>
+        <p:nvPicPr>
+          <p:cNvPr id="9" name="Picture 8" descr="heart_watch_slide_crop.png"/>
+          <p:cNvPicPr>
+            <a:picLocks noChangeAspect="1"/>
+          </p:cNvPicPr>
+          <p:nvPr/>
+        </p:nvPicPr>
+        <p:blipFill>
+          <a:blip r:embed="rId3"/>
+          <a:stretch>
+            <a:fillRect/>
+          </a:stretch>
+        </p:blipFill>
+        <p:spPr>
+          <a:xfrm>
+            <a:off x="1373623" y="1417320"/>
+            <a:ext cx="2830594" cy="3017520"/>
+          </a:xfrm>
+          <a:prstGeom prst="rect">
+            <a:avLst/>
+          </a:prstGeom>
+        </p:spPr>
+      </p:pic>
     </p:spTree>
   </p:cSld>
   <p:clrMapOvr>

</xml_diff>